<commit_message>
Update EDO practice materials
</commit_message>
<xml_diff>
--- a/edo/задание 1/Claude-for-Microsoft-365.pptx
+++ b/edo/задание 1/Claude-for-Microsoft-365.pptx
@@ -10,13 +10,14 @@
     <p:sldId id="258" r:id="rId4"/>
     <p:sldId id="259" r:id="rId5"/>
     <p:sldId id="260" r:id="rId6"/>
-    <p:sldId id="261" r:id="rId7"/>
-    <p:sldId id="262" r:id="rId8"/>
-    <p:sldId id="263" r:id="rId9"/>
-    <p:sldId id="264" r:id="rId10"/>
-    <p:sldId id="265" r:id="rId11"/>
-    <p:sldId id="266" r:id="rId12"/>
-    <p:sldId id="267" r:id="rId13"/>
+    <p:sldId id="268" r:id="rId7"/>
+    <p:sldId id="261" r:id="rId8"/>
+    <p:sldId id="262" r:id="rId9"/>
+    <p:sldId id="263" r:id="rId10"/>
+    <p:sldId id="264" r:id="rId11"/>
+    <p:sldId id="265" r:id="rId12"/>
+    <p:sldId id="266" r:id="rId13"/>
+    <p:sldId id="267" r:id="rId14"/>
   </p:sldIdLst>
   <p:sldSz cx="12192000" cy="6858000"/>
   <p:notesSz cx="6858000" cy="9144000"/>
@@ -313,7 +314,7 @@
           <a:p>
             <a:fld id="{5BCAD085-E8A6-8845-BD4E-CB4CCA059FC4}" type="datetimeFigureOut">
               <a:rPr lang="en-US" smtClean="0"/>
-              <a:t>5/20/2026</a:t>
+              <a:t>5/24/2026</a:t>
             </a:fld>
             <a:endParaRPr lang="en-US"/>
           </a:p>
@@ -481,7 +482,7 @@
           <a:p>
             <a:fld id="{5BCAD085-E8A6-8845-BD4E-CB4CCA059FC4}" type="datetimeFigureOut">
               <a:rPr lang="en-US" smtClean="0"/>
-              <a:t>5/20/2026</a:t>
+              <a:t>5/24/2026</a:t>
             </a:fld>
             <a:endParaRPr lang="en-US"/>
           </a:p>
@@ -659,7 +660,7 @@
           <a:p>
             <a:fld id="{5BCAD085-E8A6-8845-BD4E-CB4CCA059FC4}" type="datetimeFigureOut">
               <a:rPr lang="en-US" smtClean="0"/>
-              <a:t>5/20/2026</a:t>
+              <a:t>5/24/2026</a:t>
             </a:fld>
             <a:endParaRPr lang="en-US"/>
           </a:p>
@@ -827,7 +828,7 @@
           <a:p>
             <a:fld id="{5BCAD085-E8A6-8845-BD4E-CB4CCA059FC4}" type="datetimeFigureOut">
               <a:rPr lang="en-US" smtClean="0"/>
-              <a:t>5/20/2026</a:t>
+              <a:t>5/24/2026</a:t>
             </a:fld>
             <a:endParaRPr lang="en-US"/>
           </a:p>
@@ -1072,7 +1073,7 @@
           <a:p>
             <a:fld id="{5BCAD085-E8A6-8845-BD4E-CB4CCA059FC4}" type="datetimeFigureOut">
               <a:rPr lang="en-US" smtClean="0"/>
-              <a:t>5/20/2026</a:t>
+              <a:t>5/24/2026</a:t>
             </a:fld>
             <a:endParaRPr lang="en-US"/>
           </a:p>
@@ -1357,7 +1358,7 @@
           <a:p>
             <a:fld id="{5BCAD085-E8A6-8845-BD4E-CB4CCA059FC4}" type="datetimeFigureOut">
               <a:rPr lang="en-US" smtClean="0"/>
-              <a:t>5/20/2026</a:t>
+              <a:t>5/24/2026</a:t>
             </a:fld>
             <a:endParaRPr lang="en-US"/>
           </a:p>
@@ -1776,7 +1777,7 @@
           <a:p>
             <a:fld id="{5BCAD085-E8A6-8845-BD4E-CB4CCA059FC4}" type="datetimeFigureOut">
               <a:rPr lang="en-US" smtClean="0"/>
-              <a:t>5/20/2026</a:t>
+              <a:t>5/24/2026</a:t>
             </a:fld>
             <a:endParaRPr lang="en-US"/>
           </a:p>
@@ -1893,7 +1894,7 @@
           <a:p>
             <a:fld id="{5BCAD085-E8A6-8845-BD4E-CB4CCA059FC4}" type="datetimeFigureOut">
               <a:rPr lang="en-US" smtClean="0"/>
-              <a:t>5/20/2026</a:t>
+              <a:t>5/24/2026</a:t>
             </a:fld>
             <a:endParaRPr lang="en-US"/>
           </a:p>
@@ -1988,7 +1989,7 @@
           <a:p>
             <a:fld id="{5BCAD085-E8A6-8845-BD4E-CB4CCA059FC4}" type="datetimeFigureOut">
               <a:rPr lang="en-US" smtClean="0"/>
-              <a:t>5/20/2026</a:t>
+              <a:t>5/24/2026</a:t>
             </a:fld>
             <a:endParaRPr lang="en-US"/>
           </a:p>
@@ -2263,7 +2264,7 @@
           <a:p>
             <a:fld id="{5BCAD085-E8A6-8845-BD4E-CB4CCA059FC4}" type="datetimeFigureOut">
               <a:rPr lang="en-US" smtClean="0"/>
-              <a:t>5/20/2026</a:t>
+              <a:t>5/24/2026</a:t>
             </a:fld>
             <a:endParaRPr lang="en-US"/>
           </a:p>
@@ -2515,7 +2516,7 @@
           <a:p>
             <a:fld id="{5BCAD085-E8A6-8845-BD4E-CB4CCA059FC4}" type="datetimeFigureOut">
               <a:rPr lang="en-US" smtClean="0"/>
-              <a:t>5/20/2026</a:t>
+              <a:t>5/24/2026</a:t>
             </a:fld>
             <a:endParaRPr lang="en-US"/>
           </a:p>
@@ -2726,7 +2727,7 @@
           <a:p>
             <a:fld id="{5BCAD085-E8A6-8845-BD4E-CB4CCA059FC4}" type="datetimeFigureOut">
               <a:rPr lang="en-US" smtClean="0"/>
-              <a:t>5/20/2026</a:t>
+              <a:t>5/24/2026</a:t>
             </a:fld>
             <a:endParaRPr lang="en-US"/>
           </a:p>
@@ -3508,7 +3509,7 @@
                 </a:solidFill>
                 <a:latin typeface="Roboto Slab"/>
               </a:rPr>
-              <a:t>Безопасность и соответствие законодательству</a:t>
+              <a:t>Варианты поставки и тарифы</a:t>
             </a:r>
           </a:p>
         </p:txBody>
@@ -3522,7 +3523,7 @@
         <p:spPr>
           <a:xfrm>
             <a:off x="841248" y="1828800"/>
-            <a:ext cx="10515600" cy="4352544"/>
+            <a:ext cx="5074920" cy="4352544"/>
           </a:xfrm>
           <a:prstGeom prst="rect">
             <a:avLst/>
@@ -3535,6 +3536,25 @@
           </a:bodyPr>
           <a:lstStyle/>
           <a:p>
+            <a:pPr>
+              <a:spcBef>
+                <a:spcPts val="0"/>
+              </a:spcBef>
+              <a:spcAft>
+                <a:spcPts val="600"/>
+              </a:spcAft>
+            </a:pPr>
+            <a:r>
+              <a:rPr sz="2000" b="1">
+                <a:solidFill>
+                  <a:srgbClr val="3B1E5E"/>
+                </a:solidFill>
+                <a:latin typeface="Roboto"/>
+              </a:rPr>
+              <a:t>Локальная (On-Premise)</a:t>
+            </a:r>
+          </a:p>
+          <a:p>
             <a:pPr marL="285750" indent="-285750">
               <a:spcAft>
                 <a:spcPts val="400"/>
@@ -3549,7 +3569,7 @@
                 </a:solidFill>
                 <a:latin typeface="Roboto"/>
               </a:rPr>
-              <a:t>Электронная подпись — ПЭП и УКЭП, регламентируется 63-ФЗ «Об электронной подписи»</a:t>
+              <a:t>Установка на серверах заказчика</a:t>
             </a:r>
           </a:p>
           <a:p>
@@ -3567,7 +3587,7 @@
                 </a:solidFill>
                 <a:latin typeface="Roboto"/>
               </a:rPr>
-              <a:t>Криптография — поддержка ГОСТ Р 34.10-2012; лицензия ФСБ России</a:t>
+              <a:t>Полный контроль данных</a:t>
             </a:r>
           </a:p>
           <a:p>
@@ -3585,7 +3605,7 @@
                 </a:solidFill>
                 <a:latin typeface="Roboto"/>
               </a:rPr>
-              <a:t>Персональные данные — соответствие 152-ФЗ «О персональных данных»</a:t>
+              <a:t>Тарифы: Basic, Enterprise, Intelligence</a:t>
             </a:r>
           </a:p>
           <a:p>
@@ -3603,7 +3623,49 @@
                 </a:solidFill>
                 <a:latin typeface="Roboto"/>
               </a:rPr>
-              <a:t>Коммерческая тайна — соответствие 98-ФЗ «О коммерческой тайне»</a:t>
+              <a:t>Подходит для крупных компаний</a:t>
+            </a:r>
+          </a:p>
+        </p:txBody>
+      </p:sp>
+      <p:sp>
+        <p:nvSpPr>
+          <p:cNvPr id="5" name="TextBox 4"/>
+          <p:cNvSpPr txBox="1"/>
+          <p:nvPr/>
+        </p:nvSpPr>
+        <p:spPr>
+          <a:xfrm>
+            <a:off x="6272784" y="1828800"/>
+            <a:ext cx="5074920" cy="4352544"/>
+          </a:xfrm>
+          <a:prstGeom prst="rect">
+            <a:avLst/>
+          </a:prstGeom>
+          <a:noFill/>
+        </p:spPr>
+        <p:txBody>
+          <a:bodyPr wrap="square" lIns="0" tIns="0" rIns="0" bIns="0" anchor="t">
+            <a:spAutoFit/>
+          </a:bodyPr>
+          <a:lstStyle/>
+          <a:p>
+            <a:pPr>
+              <a:spcBef>
+                <a:spcPts val="0"/>
+              </a:spcBef>
+              <a:spcAft>
+                <a:spcPts val="600"/>
+              </a:spcAft>
+            </a:pPr>
+            <a:r>
+              <a:rPr sz="2000" b="1">
+                <a:solidFill>
+                  <a:srgbClr val="3B1E5E"/>
+                </a:solidFill>
+                <a:latin typeface="Roboto"/>
+              </a:rPr>
+              <a:t>Облачная (SaaS)</a:t>
             </a:r>
           </a:p>
           <a:p>
@@ -3621,7 +3683,61 @@
                 </a:solidFill>
                 <a:latin typeface="Roboto"/>
               </a:rPr>
-              <a:t>Контроль доступа — гибкая настройка прав, аудит действий, история работы с документами</a:t>
+              <a:t>Размещение в ЦОД на территории РФ</a:t>
+            </a:r>
+          </a:p>
+          <a:p>
+            <a:pPr marL="285750" indent="-285750">
+              <a:spcAft>
+                <a:spcPts val="400"/>
+              </a:spcAft>
+              <a:buFont typeface="Arial"/>
+              <a:buChar char="•"/>
+            </a:pPr>
+            <a:r>
+              <a:rPr sz="1700" b="0">
+                <a:solidFill>
+                  <a:srgbClr val="1F1530"/>
+                </a:solidFill>
+                <a:latin typeface="Roboto"/>
+              </a:rPr>
+              <a:t>Быстрый старт, без капвложений</a:t>
+            </a:r>
+          </a:p>
+          <a:p>
+            <a:pPr marL="285750" indent="-285750">
+              <a:spcAft>
+                <a:spcPts val="400"/>
+              </a:spcAft>
+              <a:buFont typeface="Arial"/>
+              <a:buChar char="•"/>
+            </a:pPr>
+            <a:r>
+              <a:rPr sz="1700" b="0">
+                <a:solidFill>
+                  <a:srgbClr val="1F1530"/>
+                </a:solidFill>
+                <a:latin typeface="Roboto"/>
+              </a:rPr>
+              <a:t>Тарифы: RX100 (до 200), DRX200</a:t>
+            </a:r>
+          </a:p>
+          <a:p>
+            <a:pPr marL="285750" indent="-285750">
+              <a:spcAft>
+                <a:spcPts val="400"/>
+              </a:spcAft>
+              <a:buFont typeface="Arial"/>
+              <a:buChar char="•"/>
+            </a:pPr>
+            <a:r>
+              <a:rPr sz="1700" b="0">
+                <a:solidFill>
+                  <a:srgbClr val="1F1530"/>
+                </a:solidFill>
+                <a:latin typeface="Roboto"/>
+              </a:rPr>
+              <a:t>Подходит для среднего и малого бизнеса</a:t>
             </a:r>
           </a:p>
         </p:txBody>
@@ -3725,7 +3841,7 @@
                 </a:solidFill>
                 <a:latin typeface="Roboto Slab"/>
               </a:rPr>
-              <a:t>Примеры внедрения</a:t>
+              <a:t>Безопасность и соответствие законодательству</a:t>
             </a:r>
           </a:p>
         </p:txBody>
@@ -3766,7 +3882,7 @@
                 </a:solidFill>
                 <a:latin typeface="Roboto"/>
               </a:rPr>
-              <a:t>Росбанк — интеллектуальное распознавание документов от госорганов и клиентов</a:t>
+              <a:t>Электронная подпись — ПЭП и УКЭП, регламентируется 63-ФЗ «Об электронной подписи»</a:t>
             </a:r>
           </a:p>
           <a:p>
@@ -3784,7 +3900,7 @@
                 </a:solidFill>
                 <a:latin typeface="Roboto"/>
               </a:rPr>
-              <a:t>Группа компаний «Эталон» — переход на единую корпоративную СЭД</a:t>
+              <a:t>Криптография — поддержка ГОСТ Р 34.10-2012; лицензия ФСБ России</a:t>
             </a:r>
           </a:p>
           <a:p>
@@ -3802,7 +3918,7 @@
                 </a:solidFill>
                 <a:latin typeface="Roboto"/>
               </a:rPr>
-              <a:t>ESTEL — кадровый электронный документооборот (КЭДО)</a:t>
+              <a:t>Персональные данные — соответствие 152-ФЗ «О персональных данных»</a:t>
             </a:r>
           </a:p>
           <a:p>
@@ -3820,7 +3936,7 @@
                 </a:solidFill>
                 <a:latin typeface="Roboto"/>
               </a:rPr>
-              <a:t>АО «Роскартография» — автоматизация делопроизводства и согласований</a:t>
+              <a:t>Коммерческая тайна — соответствие 98-ФЗ «О коммерческой тайне»</a:t>
             </a:r>
           </a:p>
           <a:p>
@@ -3838,25 +3954,7 @@
                 </a:solidFill>
                 <a:latin typeface="Roboto"/>
               </a:rPr>
-              <a:t>ОДК — интеллектуальная обработка входящей корреспонденции</a:t>
-            </a:r>
-          </a:p>
-          <a:p>
-            <a:pPr marL="285750" indent="-285750">
-              <a:spcAft>
-                <a:spcPts val="400"/>
-              </a:spcAft>
-              <a:buFont typeface="Arial"/>
-              <a:buChar char="•"/>
-            </a:pPr>
-            <a:r>
-              <a:rPr sz="1700" b="0">
-                <a:solidFill>
-                  <a:srgbClr val="1F1530"/>
-                </a:solidFill>
-                <a:latin typeface="Roboto"/>
-              </a:rPr>
-              <a:t>Правительства регионов РФ — Тюменская, Омская, Курганская, Владимирская области</a:t>
+              <a:t>Контроль доступа — гибкая настройка прав, аудит действий, история работы с документами</a:t>
             </a:r>
           </a:p>
         </p:txBody>
@@ -3960,7 +4058,7 @@
                 </a:solidFill>
                 <a:latin typeface="Roboto Slab"/>
               </a:rPr>
-              <a:t>Заключение</a:t>
+              <a:t>Примеры внедрения</a:t>
             </a:r>
           </a:p>
         </p:txBody>
@@ -3987,159 +4085,111 @@
           </a:bodyPr>
           <a:lstStyle/>
           <a:p>
-            <a:pPr>
-              <a:spcBef>
-                <a:spcPts val="0"/>
-              </a:spcBef>
+            <a:pPr marL="285750" indent="-285750">
               <a:spcAft>
                 <a:spcPts val="400"/>
               </a:spcAft>
-            </a:pPr>
-            <a:r>
-              <a:rPr sz="1800" b="1">
-                <a:solidFill>
-                  <a:srgbClr val="3B1E5E"/>
-                </a:solidFill>
-                <a:latin typeface="Roboto"/>
-              </a:rPr>
-              <a:t>Универсальное решение</a:t>
-            </a:r>
-          </a:p>
-          <a:p>
-            <a:pPr>
-              <a:spcAft>
-                <a:spcPts val="600"/>
-              </a:spcAft>
-            </a:pPr>
-            <a:r>
-              <a:rPr sz="1800" b="0">
+              <a:buFont typeface="Arial"/>
+              <a:buChar char="•"/>
+            </a:pPr>
+            <a:r>
+              <a:rPr sz="1700" b="0">
                 <a:solidFill>
                   <a:srgbClr val="1F1530"/>
                 </a:solidFill>
                 <a:latin typeface="Roboto"/>
               </a:rPr>
-              <a:t>Directum RX закрывает весь цикл документооборота — от создания документа до архива.</a:t>
-            </a:r>
-          </a:p>
-          <a:p>
-            <a:pPr>
-              <a:spcBef>
-                <a:spcPts val="1000"/>
-              </a:spcBef>
+              <a:t>Росбанк — интеллектуальное распознавание документов от госорганов и клиентов</a:t>
+            </a:r>
+          </a:p>
+          <a:p>
+            <a:pPr marL="285750" indent="-285750">
               <a:spcAft>
                 <a:spcPts val="400"/>
               </a:spcAft>
-            </a:pPr>
-            <a:r>
-              <a:rPr sz="1800" b="1">
-                <a:solidFill>
-                  <a:srgbClr val="3B1E5E"/>
-                </a:solidFill>
-                <a:latin typeface="Roboto"/>
-              </a:rPr>
-              <a:t>Российская разработка</a:t>
-            </a:r>
-          </a:p>
-          <a:p>
-            <a:pPr>
-              <a:spcAft>
-                <a:spcPts val="600"/>
-              </a:spcAft>
-            </a:pPr>
-            <a:r>
-              <a:rPr sz="1800" b="0">
+              <a:buFont typeface="Arial"/>
+              <a:buChar char="•"/>
+            </a:pPr>
+            <a:r>
+              <a:rPr sz="1700" b="0">
                 <a:solidFill>
                   <a:srgbClr val="1F1530"/>
                 </a:solidFill>
                 <a:latin typeface="Roboto"/>
               </a:rPr>
-              <a:t>Полное соответствие законодательству РФ и независимость от зарубежного ПО.</a:t>
-            </a:r>
-          </a:p>
-          <a:p>
-            <a:pPr>
-              <a:spcBef>
-                <a:spcPts val="1000"/>
-              </a:spcBef>
+              <a:t>Группа компаний «Эталон» — переход на единую корпоративную СЭД</a:t>
+            </a:r>
+          </a:p>
+          <a:p>
+            <a:pPr marL="285750" indent="-285750">
               <a:spcAft>
                 <a:spcPts val="400"/>
               </a:spcAft>
-            </a:pPr>
-            <a:r>
-              <a:rPr sz="1800" b="1">
-                <a:solidFill>
-                  <a:srgbClr val="3B1E5E"/>
-                </a:solidFill>
-                <a:latin typeface="Roboto"/>
-              </a:rPr>
-              <a:t>Интеллектуальные сервисы</a:t>
-            </a:r>
-          </a:p>
-          <a:p>
-            <a:pPr>
-              <a:spcAft>
-                <a:spcPts val="600"/>
-              </a:spcAft>
-            </a:pPr>
-            <a:r>
-              <a:rPr sz="1800" b="0">
+              <a:buFont typeface="Arial"/>
+              <a:buChar char="•"/>
+            </a:pPr>
+            <a:r>
+              <a:rPr sz="1700" b="0">
                 <a:solidFill>
                   <a:srgbClr val="1F1530"/>
                 </a:solidFill>
                 <a:latin typeface="Roboto"/>
               </a:rPr>
-              <a:t>ИИ Directum Ario автоматизирует рутинные операции и снижает нагрузку на сотрудников.</a:t>
-            </a:r>
-          </a:p>
-          <a:p>
-            <a:pPr>
-              <a:spcBef>
-                <a:spcPts val="1000"/>
-              </a:spcBef>
+              <a:t>ESTEL — кадровый электронный документооборот (КЭДО)</a:t>
+            </a:r>
+          </a:p>
+          <a:p>
+            <a:pPr marL="285750" indent="-285750">
               <a:spcAft>
                 <a:spcPts val="400"/>
               </a:spcAft>
-            </a:pPr>
-            <a:r>
-              <a:rPr sz="1800" b="1">
-                <a:solidFill>
-                  <a:srgbClr val="3B1E5E"/>
-                </a:solidFill>
-                <a:latin typeface="Roboto"/>
-              </a:rPr>
-              <a:t>Гибкость поставки</a:t>
-            </a:r>
-          </a:p>
-          <a:p>
-            <a:pPr>
-              <a:spcAft>
-                <a:spcPts val="600"/>
-              </a:spcAft>
-            </a:pPr>
-            <a:r>
-              <a:rPr sz="1800" b="0">
+              <a:buFont typeface="Arial"/>
+              <a:buChar char="•"/>
+            </a:pPr>
+            <a:r>
+              <a:rPr sz="1700" b="0">
                 <a:solidFill>
                   <a:srgbClr val="1F1530"/>
                 </a:solidFill>
                 <a:latin typeface="Roboto"/>
               </a:rPr>
-              <a:t>Облачные и локальные варианты подходят бизнесу любого масштаба — от 50 до 50 000 пользователей.</a:t>
-            </a:r>
-          </a:p>
-          <a:p>
-            <a:pPr>
-              <a:spcAft>
-                <a:spcPts val="600"/>
-              </a:spcAft>
-            </a:pPr>
-            <a:r>
-              <a:rPr sz="1800" b="0">
+              <a:t>АО «Роскартография» — автоматизация делопроизводства и согласований</a:t>
+            </a:r>
+          </a:p>
+          <a:p>
+            <a:pPr marL="285750" indent="-285750">
+              <a:spcAft>
+                <a:spcPts val="400"/>
+              </a:spcAft>
+              <a:buFont typeface="Arial"/>
+              <a:buChar char="•"/>
+            </a:pPr>
+            <a:r>
+              <a:rPr sz="1700" b="0">
                 <a:solidFill>
                   <a:srgbClr val="1F1530"/>
                 </a:solidFill>
                 <a:latin typeface="Roboto"/>
               </a:rPr>
-              <a:t>Источники: directum.ru, ru.wikipedia.org/wiki/Directum, tadviser.ru</a:t>
+              <a:t>ОДК — интеллектуальная обработка входящей корреспонденции</a:t>
+            </a:r>
+          </a:p>
+          <a:p>
+            <a:pPr marL="285750" indent="-285750">
+              <a:spcAft>
+                <a:spcPts val="400"/>
+              </a:spcAft>
+              <a:buFont typeface="Arial"/>
+              <a:buChar char="•"/>
+            </a:pPr>
+            <a:r>
+              <a:rPr sz="1700" b="0">
+                <a:solidFill>
+                  <a:srgbClr val="1F1530"/>
+                </a:solidFill>
+                <a:latin typeface="Roboto"/>
+              </a:rPr>
+              <a:t>Правительства регионов РФ — Тюменская, Омская, Курганская, Владимирская области</a:t>
             </a:r>
           </a:p>
         </p:txBody>
@@ -4152,7 +4202,7 @@
 </p:sld>
 </file>
 
-<file path=ppt/slides/slide2.xml><?xml version="1.0" encoding="utf-8"?>
+<file path=ppt/slides/slide13.xml><?xml version="1.0" encoding="utf-8"?>
 <p:sld xmlns:a="http://schemas.openxmlformats.org/drawingml/2006/main" xmlns:r="http://schemas.openxmlformats.org/officeDocument/2006/relationships" xmlns:p="http://schemas.openxmlformats.org/presentationml/2006/main">
   <p:cSld>
     <p:spTree>
@@ -4243,7 +4293,7 @@
                 </a:solidFill>
                 <a:latin typeface="Roboto Slab"/>
               </a:rPr>
-              <a:t>Содержание</a:t>
+              <a:t>Заключение</a:t>
             </a:r>
           </a:p>
         </p:txBody>
@@ -4270,183 +4320,159 @@
           </a:bodyPr>
           <a:lstStyle/>
           <a:p>
-            <a:pPr marL="285750" indent="-285750">
+            <a:pPr>
+              <a:spcBef>
+                <a:spcPts val="0"/>
+              </a:spcBef>
               <a:spcAft>
                 <a:spcPts val="400"/>
               </a:spcAft>
-              <a:buFont typeface="Arial"/>
-              <a:buChar char="•"/>
-            </a:pPr>
-            <a:r>
-              <a:rPr sz="1700" b="0">
+            </a:pPr>
+            <a:r>
+              <a:rPr sz="1800" b="1">
+                <a:solidFill>
+                  <a:srgbClr val="3B1E5E"/>
+                </a:solidFill>
+                <a:latin typeface="Roboto"/>
+              </a:rPr>
+              <a:t>Универсальное решение</a:t>
+            </a:r>
+          </a:p>
+          <a:p>
+            <a:pPr>
+              <a:spcAft>
+                <a:spcPts val="600"/>
+              </a:spcAft>
+            </a:pPr>
+            <a:r>
+              <a:rPr sz="1800" b="0">
                 <a:solidFill>
                   <a:srgbClr val="1F1530"/>
                 </a:solidFill>
                 <a:latin typeface="Roboto"/>
               </a:rPr>
-              <a:t>01.  Понятие СЭД и её задачи</a:t>
-            </a:r>
-          </a:p>
-          <a:p>
-            <a:pPr marL="285750" indent="-285750">
+              <a:t>Directum RX закрывает весь цикл документооборота — от создания документа до архива.</a:t>
+            </a:r>
+          </a:p>
+          <a:p>
+            <a:pPr>
+              <a:spcBef>
+                <a:spcPts val="1000"/>
+              </a:spcBef>
               <a:spcAft>
                 <a:spcPts val="400"/>
               </a:spcAft>
-              <a:buFont typeface="Arial"/>
-              <a:buChar char="•"/>
-            </a:pPr>
-            <a:r>
-              <a:rPr sz="1700" b="0">
+            </a:pPr>
+            <a:r>
+              <a:rPr sz="1800" b="1">
+                <a:solidFill>
+                  <a:srgbClr val="3B1E5E"/>
+                </a:solidFill>
+                <a:latin typeface="Roboto"/>
+              </a:rPr>
+              <a:t>Российская разработка</a:t>
+            </a:r>
+          </a:p>
+          <a:p>
+            <a:pPr>
+              <a:spcAft>
+                <a:spcPts val="600"/>
+              </a:spcAft>
+            </a:pPr>
+            <a:r>
+              <a:rPr sz="1800" b="0">
                 <a:solidFill>
                   <a:srgbClr val="1F1530"/>
                 </a:solidFill>
                 <a:latin typeface="Roboto"/>
               </a:rPr>
-              <a:t>02.  Преимущества внедрения</a:t>
-            </a:r>
-          </a:p>
-          <a:p>
-            <a:pPr marL="285750" indent="-285750">
+              <a:t>Полное соответствие законодательству РФ и независимость от зарубежного ПО.</a:t>
+            </a:r>
+          </a:p>
+          <a:p>
+            <a:pPr>
+              <a:spcBef>
+                <a:spcPts val="1000"/>
+              </a:spcBef>
               <a:spcAft>
                 <a:spcPts val="400"/>
               </a:spcAft>
-              <a:buFont typeface="Arial"/>
-              <a:buChar char="•"/>
-            </a:pPr>
-            <a:r>
-              <a:rPr sz="1700" b="0">
+            </a:pPr>
+            <a:r>
+              <a:rPr sz="1800" b="1">
+                <a:solidFill>
+                  <a:srgbClr val="3B1E5E"/>
+                </a:solidFill>
+                <a:latin typeface="Roboto"/>
+              </a:rPr>
+              <a:t>Интеллектуальные сервисы</a:t>
+            </a:r>
+          </a:p>
+          <a:p>
+            <a:pPr>
+              <a:spcAft>
+                <a:spcPts val="600"/>
+              </a:spcAft>
+            </a:pPr>
+            <a:r>
+              <a:rPr sz="1800" b="0">
                 <a:solidFill>
                   <a:srgbClr val="1F1530"/>
                 </a:solidFill>
                 <a:latin typeface="Roboto"/>
               </a:rPr>
-              <a:t>03.  Общие сведения о Directum RX</a:t>
-            </a:r>
-          </a:p>
-          <a:p>
-            <a:pPr marL="285750" indent="-285750">
+              <a:t>ИИ Directum Ario автоматизирует рутинные операции и снижает нагрузку на сотрудников.</a:t>
+            </a:r>
+          </a:p>
+          <a:p>
+            <a:pPr>
+              <a:spcBef>
+                <a:spcPts val="1000"/>
+              </a:spcBef>
               <a:spcAft>
                 <a:spcPts val="400"/>
               </a:spcAft>
-              <a:buFont typeface="Arial"/>
-              <a:buChar char="•"/>
-            </a:pPr>
-            <a:r>
-              <a:rPr sz="1700" b="0">
+            </a:pPr>
+            <a:r>
+              <a:rPr sz="1800" b="1">
+                <a:solidFill>
+                  <a:srgbClr val="3B1E5E"/>
+                </a:solidFill>
+                <a:latin typeface="Roboto"/>
+              </a:rPr>
+              <a:t>Гибкость поставки</a:t>
+            </a:r>
+          </a:p>
+          <a:p>
+            <a:pPr>
+              <a:spcAft>
+                <a:spcPts val="600"/>
+              </a:spcAft>
+            </a:pPr>
+            <a:r>
+              <a:rPr sz="1800" b="0">
                 <a:solidFill>
                   <a:srgbClr val="1F1530"/>
                 </a:solidFill>
                 <a:latin typeface="Roboto"/>
               </a:rPr>
-              <a:t>04.  Архитектура и платформы</a:t>
-            </a:r>
-          </a:p>
-          <a:p>
-            <a:pPr marL="285750" indent="-285750">
-              <a:spcAft>
-                <a:spcPts val="400"/>
-              </a:spcAft>
-              <a:buFont typeface="Arial"/>
-              <a:buChar char="•"/>
-            </a:pPr>
-            <a:r>
-              <a:rPr sz="1700" b="0">
+              <a:t>Облачные и локальные варианты подходят бизнесу любого масштаба — от 50 до 50 000 пользователей.</a:t>
+            </a:r>
+          </a:p>
+          <a:p>
+            <a:pPr>
+              <a:spcAft>
+                <a:spcPts val="600"/>
+              </a:spcAft>
+            </a:pPr>
+            <a:r>
+              <a:rPr sz="1800" b="0">
                 <a:solidFill>
                   <a:srgbClr val="1F1530"/>
                 </a:solidFill>
                 <a:latin typeface="Roboto"/>
               </a:rPr>
-              <a:t>05.  Основные функции</a:t>
-            </a:r>
-          </a:p>
-          <a:p>
-            <a:pPr marL="285750" indent="-285750">
-              <a:spcAft>
-                <a:spcPts val="400"/>
-              </a:spcAft>
-              <a:buFont typeface="Arial"/>
-              <a:buChar char="•"/>
-            </a:pPr>
-            <a:r>
-              <a:rPr sz="1700" b="0">
-                <a:solidFill>
-                  <a:srgbClr val="1F1530"/>
-                </a:solidFill>
-                <a:latin typeface="Roboto"/>
-              </a:rPr>
-              <a:t>06.  Интеллектуальные сервисы Ario</a:t>
-            </a:r>
-          </a:p>
-          <a:p>
-            <a:pPr marL="285750" indent="-285750">
-              <a:spcAft>
-                <a:spcPts val="400"/>
-              </a:spcAft>
-              <a:buFont typeface="Arial"/>
-              <a:buChar char="•"/>
-            </a:pPr>
-            <a:r>
-              <a:rPr sz="1700" b="0">
-                <a:solidFill>
-                  <a:srgbClr val="1F1530"/>
-                </a:solidFill>
-                <a:latin typeface="Roboto"/>
-              </a:rPr>
-              <a:t>07.  Варианты поставки и тарифы</a:t>
-            </a:r>
-          </a:p>
-          <a:p>
-            <a:pPr marL="285750" indent="-285750">
-              <a:spcAft>
-                <a:spcPts val="400"/>
-              </a:spcAft>
-              <a:buFont typeface="Arial"/>
-              <a:buChar char="•"/>
-            </a:pPr>
-            <a:r>
-              <a:rPr sz="1700" b="0">
-                <a:solidFill>
-                  <a:srgbClr val="1F1530"/>
-                </a:solidFill>
-                <a:latin typeface="Roboto"/>
-              </a:rPr>
-              <a:t>08.  Безопасность</a:t>
-            </a:r>
-          </a:p>
-          <a:p>
-            <a:pPr marL="285750" indent="-285750">
-              <a:spcAft>
-                <a:spcPts val="400"/>
-              </a:spcAft>
-              <a:buFont typeface="Arial"/>
-              <a:buChar char="•"/>
-            </a:pPr>
-            <a:r>
-              <a:rPr sz="1700" b="0">
-                <a:solidFill>
-                  <a:srgbClr val="1F1530"/>
-                </a:solidFill>
-                <a:latin typeface="Roboto"/>
-              </a:rPr>
-              <a:t>09.  Примеры внедрения</a:t>
-            </a:r>
-          </a:p>
-          <a:p>
-            <a:pPr marL="285750" indent="-285750">
-              <a:spcAft>
-                <a:spcPts val="400"/>
-              </a:spcAft>
-              <a:buFont typeface="Arial"/>
-              <a:buChar char="•"/>
-            </a:pPr>
-            <a:r>
-              <a:rPr sz="1700" b="0">
-                <a:solidFill>
-                  <a:srgbClr val="1F1530"/>
-                </a:solidFill>
-                <a:latin typeface="Roboto"/>
-              </a:rPr>
-              <a:t>10.  Заключение</a:t>
+              <a:t>Источники: directum.ru, ru.wikipedia.org/wiki/Directum, tadviser.ru</a:t>
             </a:r>
           </a:p>
         </p:txBody>
@@ -4459,7 +4485,7 @@
 </p:sld>
 </file>
 
-<file path=ppt/slides/slide3.xml><?xml version="1.0" encoding="utf-8"?>
+<file path=ppt/slides/slide2.xml><?xml version="1.0" encoding="utf-8"?>
 <p:sld xmlns:a="http://schemas.openxmlformats.org/drawingml/2006/main" xmlns:r="http://schemas.openxmlformats.org/officeDocument/2006/relationships" xmlns:p="http://schemas.openxmlformats.org/presentationml/2006/main">
   <p:cSld>
     <p:spTree>
@@ -4550,7 +4576,7 @@
                 </a:solidFill>
                 <a:latin typeface="Roboto Slab"/>
               </a:rPr>
-              <a:t>Что такое СЭД?</a:t>
+              <a:t>Содержание</a:t>
             </a:r>
           </a:p>
         </p:txBody>
@@ -4577,60 +4603,6 @@
           </a:bodyPr>
           <a:lstStyle/>
           <a:p>
-            <a:pPr>
-              <a:spcBef>
-                <a:spcPts val="0"/>
-              </a:spcBef>
-              <a:spcAft>
-                <a:spcPts val="400"/>
-              </a:spcAft>
-            </a:pPr>
-            <a:r>
-              <a:rPr sz="1800" b="1">
-                <a:solidFill>
-                  <a:srgbClr val="3B1E5E"/>
-                </a:solidFill>
-                <a:latin typeface="Roboto"/>
-              </a:rPr>
-              <a:t>Определение</a:t>
-            </a:r>
-          </a:p>
-          <a:p>
-            <a:pPr>
-              <a:spcAft>
-                <a:spcPts val="600"/>
-              </a:spcAft>
-            </a:pPr>
-            <a:r>
-              <a:rPr sz="1800" b="0">
-                <a:solidFill>
-                  <a:srgbClr val="1F1530"/>
-                </a:solidFill>
-                <a:latin typeface="Roboto"/>
-              </a:rPr>
-              <a:t>Система электронного документооборота (СЭД) — программный комплекс для автоматизации работы с электронными документами на всём жизненном цикле: от создания до архивного хранения.</a:t>
-            </a:r>
-          </a:p>
-          <a:p>
-            <a:pPr>
-              <a:spcBef>
-                <a:spcPts val="1000"/>
-              </a:spcBef>
-              <a:spcAft>
-                <a:spcPts val="400"/>
-              </a:spcAft>
-            </a:pPr>
-            <a:r>
-              <a:rPr sz="1800" b="1">
-                <a:solidFill>
-                  <a:srgbClr val="3B1E5E"/>
-                </a:solidFill>
-                <a:latin typeface="Roboto"/>
-              </a:rPr>
-              <a:t>Основные задачи СЭД:</a:t>
-            </a:r>
-          </a:p>
-          <a:p>
             <a:pPr marL="285750" indent="-285750">
               <a:spcAft>
                 <a:spcPts val="400"/>
@@ -4645,7 +4617,7 @@
                 </a:solidFill>
                 <a:latin typeface="Roboto"/>
               </a:rPr>
-              <a:t>создание, согласование и подписание документов</a:t>
+              <a:t>01.  Понятие СЭД и её задачи</a:t>
             </a:r>
           </a:p>
           <a:p>
@@ -4663,7 +4635,7 @@
                 </a:solidFill>
                 <a:latin typeface="Roboto"/>
               </a:rPr>
-              <a:t>регистрация, маршрутизация и контроль исполнения</a:t>
+              <a:t>02.  Преимущества внедрения</a:t>
             </a:r>
           </a:p>
           <a:p>
@@ -4681,7 +4653,7 @@
                 </a:solidFill>
                 <a:latin typeface="Roboto"/>
               </a:rPr>
-              <a:t>хранение и поиск, разграничение прав доступа</a:t>
+              <a:t>03.  Общие сведения о Directum RX</a:t>
             </a:r>
           </a:p>
           <a:p>
@@ -4699,7 +4671,115 @@
                 </a:solidFill>
                 <a:latin typeface="Roboto"/>
               </a:rPr>
-              <a:t>обеспечение юридической значимости электронной подписью</a:t>
+              <a:t>04.  Архитектура и платформы</a:t>
+            </a:r>
+          </a:p>
+          <a:p>
+            <a:pPr marL="285750" indent="-285750">
+              <a:spcAft>
+                <a:spcPts val="400"/>
+              </a:spcAft>
+              <a:buFont typeface="Arial"/>
+              <a:buChar char="•"/>
+            </a:pPr>
+            <a:r>
+              <a:rPr sz="1700" b="0">
+                <a:solidFill>
+                  <a:srgbClr val="1F1530"/>
+                </a:solidFill>
+                <a:latin typeface="Roboto"/>
+              </a:rPr>
+              <a:t>05.  Основные функции</a:t>
+            </a:r>
+          </a:p>
+          <a:p>
+            <a:pPr marL="285750" indent="-285750">
+              <a:spcAft>
+                <a:spcPts val="400"/>
+              </a:spcAft>
+              <a:buFont typeface="Arial"/>
+              <a:buChar char="•"/>
+            </a:pPr>
+            <a:r>
+              <a:rPr sz="1700" b="0">
+                <a:solidFill>
+                  <a:srgbClr val="1F1530"/>
+                </a:solidFill>
+                <a:latin typeface="Roboto"/>
+              </a:rPr>
+              <a:t>06.  Интеллектуальные сервисы Ario</a:t>
+            </a:r>
+          </a:p>
+          <a:p>
+            <a:pPr marL="285750" indent="-285750">
+              <a:spcAft>
+                <a:spcPts val="400"/>
+              </a:spcAft>
+              <a:buFont typeface="Arial"/>
+              <a:buChar char="•"/>
+            </a:pPr>
+            <a:r>
+              <a:rPr sz="1700" b="0">
+                <a:solidFill>
+                  <a:srgbClr val="1F1530"/>
+                </a:solidFill>
+                <a:latin typeface="Roboto"/>
+              </a:rPr>
+              <a:t>07.  Варианты поставки и тарифы</a:t>
+            </a:r>
+          </a:p>
+          <a:p>
+            <a:pPr marL="285750" indent="-285750">
+              <a:spcAft>
+                <a:spcPts val="400"/>
+              </a:spcAft>
+              <a:buFont typeface="Arial"/>
+              <a:buChar char="•"/>
+            </a:pPr>
+            <a:r>
+              <a:rPr sz="1700" b="0">
+                <a:solidFill>
+                  <a:srgbClr val="1F1530"/>
+                </a:solidFill>
+                <a:latin typeface="Roboto"/>
+              </a:rPr>
+              <a:t>08.  Безопасность</a:t>
+            </a:r>
+          </a:p>
+          <a:p>
+            <a:pPr marL="285750" indent="-285750">
+              <a:spcAft>
+                <a:spcPts val="400"/>
+              </a:spcAft>
+              <a:buFont typeface="Arial"/>
+              <a:buChar char="•"/>
+            </a:pPr>
+            <a:r>
+              <a:rPr sz="1700" b="0">
+                <a:solidFill>
+                  <a:srgbClr val="1F1530"/>
+                </a:solidFill>
+                <a:latin typeface="Roboto"/>
+              </a:rPr>
+              <a:t>09.  Примеры внедрения</a:t>
+            </a:r>
+          </a:p>
+          <a:p>
+            <a:pPr marL="285750" indent="-285750">
+              <a:spcAft>
+                <a:spcPts val="400"/>
+              </a:spcAft>
+              <a:buFont typeface="Arial"/>
+              <a:buChar char="•"/>
+            </a:pPr>
+            <a:r>
+              <a:rPr sz="1700" b="0">
+                <a:solidFill>
+                  <a:srgbClr val="1F1530"/>
+                </a:solidFill>
+                <a:latin typeface="Roboto"/>
+              </a:rPr>
+              <a:t>10.  Заключение</a:t>
             </a:r>
           </a:p>
         </p:txBody>
@@ -4712,7 +4792,7 @@
 </p:sld>
 </file>
 
-<file path=ppt/slides/slide4.xml><?xml version="1.0" encoding="utf-8"?>
+<file path=ppt/slides/slide3.xml><?xml version="1.0" encoding="utf-8"?>
 <p:sld xmlns:a="http://schemas.openxmlformats.org/drawingml/2006/main" xmlns:r="http://schemas.openxmlformats.org/officeDocument/2006/relationships" xmlns:p="http://schemas.openxmlformats.org/presentationml/2006/main">
   <p:cSld>
     <p:spTree>
@@ -4803,7 +4883,7 @@
                 </a:solidFill>
                 <a:latin typeface="Roboto Slab"/>
               </a:rPr>
-              <a:t>Преимущества внедрения СЭД</a:t>
+              <a:t>Что такое СЭД?</a:t>
             </a:r>
           </a:p>
         </p:txBody>
@@ -4830,6 +4910,60 @@
           </a:bodyPr>
           <a:lstStyle/>
           <a:p>
+            <a:pPr>
+              <a:spcBef>
+                <a:spcPts val="0"/>
+              </a:spcBef>
+              <a:spcAft>
+                <a:spcPts val="400"/>
+              </a:spcAft>
+            </a:pPr>
+            <a:r>
+              <a:rPr sz="1800" b="1">
+                <a:solidFill>
+                  <a:srgbClr val="3B1E5E"/>
+                </a:solidFill>
+                <a:latin typeface="Roboto"/>
+              </a:rPr>
+              <a:t>Определение</a:t>
+            </a:r>
+          </a:p>
+          <a:p>
+            <a:pPr>
+              <a:spcAft>
+                <a:spcPts val="600"/>
+              </a:spcAft>
+            </a:pPr>
+            <a:r>
+              <a:rPr sz="1800" b="0">
+                <a:solidFill>
+                  <a:srgbClr val="1F1530"/>
+                </a:solidFill>
+                <a:latin typeface="Roboto"/>
+              </a:rPr>
+              <a:t>Система электронного документооборота (СЭД) — программный комплекс для автоматизации работы с электронными документами на всём жизненном цикле: от создания до архивного хранения.</a:t>
+            </a:r>
+          </a:p>
+          <a:p>
+            <a:pPr>
+              <a:spcBef>
+                <a:spcPts val="1000"/>
+              </a:spcBef>
+              <a:spcAft>
+                <a:spcPts val="400"/>
+              </a:spcAft>
+            </a:pPr>
+            <a:r>
+              <a:rPr sz="1800" b="1">
+                <a:solidFill>
+                  <a:srgbClr val="3B1E5E"/>
+                </a:solidFill>
+                <a:latin typeface="Roboto"/>
+              </a:rPr>
+              <a:t>Основные задачи СЭД:</a:t>
+            </a:r>
+          </a:p>
+          <a:p>
             <a:pPr marL="285750" indent="-285750">
               <a:spcAft>
                 <a:spcPts val="400"/>
@@ -4844,7 +4978,7 @@
                 </a:solidFill>
                 <a:latin typeface="Roboto"/>
               </a:rPr>
-              <a:t>Ускорение бизнес-процессов — сокращение времени согласования и подписания документов в 3–5 раз</a:t>
+              <a:t>создание, согласование и подписание документов</a:t>
             </a:r>
           </a:p>
           <a:p>
@@ -4862,7 +4996,7 @@
                 </a:solidFill>
                 <a:latin typeface="Roboto"/>
               </a:rPr>
-              <a:t>Снижение затрат — экономия на бумаге, печати, доставке и хранении документов</a:t>
+              <a:t>регистрация, маршрутизация и контроль исполнения</a:t>
             </a:r>
           </a:p>
           <a:p>
@@ -4880,7 +5014,7 @@
                 </a:solidFill>
                 <a:latin typeface="Roboto"/>
               </a:rPr>
-              <a:t>Прозрачность и контроль — отслеживание статуса документов и истории всех действий</a:t>
+              <a:t>хранение и поиск, разграничение прав доступа</a:t>
             </a:r>
           </a:p>
           <a:p>
@@ -4898,25 +5032,7 @@
                 </a:solidFill>
                 <a:latin typeface="Roboto"/>
               </a:rPr>
-              <a:t>Безопасность данных — разграничение прав доступа, защита от потери и несанкционированного использования</a:t>
-            </a:r>
-          </a:p>
-          <a:p>
-            <a:pPr marL="285750" indent="-285750">
-              <a:spcAft>
-                <a:spcPts val="400"/>
-              </a:spcAft>
-              <a:buFont typeface="Arial"/>
-              <a:buChar char="•"/>
-            </a:pPr>
-            <a:r>
-              <a:rPr sz="1700" b="0">
-                <a:solidFill>
-                  <a:srgbClr val="1F1530"/>
-                </a:solidFill>
-                <a:latin typeface="Roboto"/>
-              </a:rPr>
-              <a:t>Удалённая работа — доступ к документам из любой точки через веб и мобильные приложения</a:t>
+              <a:t>обеспечение юридической значимости электронной подписью</a:t>
             </a:r>
           </a:p>
         </p:txBody>
@@ -4929,7 +5045,7 @@
 </p:sld>
 </file>
 
-<file path=ppt/slides/slide5.xml><?xml version="1.0" encoding="utf-8"?>
+<file path=ppt/slides/slide4.xml><?xml version="1.0" encoding="utf-8"?>
 <p:sld xmlns:a="http://schemas.openxmlformats.org/drawingml/2006/main" xmlns:r="http://schemas.openxmlformats.org/officeDocument/2006/relationships" xmlns:p="http://schemas.openxmlformats.org/presentationml/2006/main">
   <p:cSld>
     <p:spTree>
@@ -5020,7 +5136,7 @@
                 </a:solidFill>
                 <a:latin typeface="Roboto Slab"/>
               </a:rPr>
-              <a:t>Directum RX — общие сведения</a:t>
+              <a:t>Преимущества внедрения СЭД</a:t>
             </a:r>
           </a:p>
         </p:txBody>
@@ -5061,7 +5177,7 @@
                 </a:solidFill>
                 <a:latin typeface="Roboto"/>
               </a:rPr>
-              <a:t>Разработчик: ООО «ДИРЕКТУМ» (Россия)</a:t>
+              <a:t>Ускорение бизнес-процессов — сокращение времени согласования и подписания документов в 3–5 раз</a:t>
             </a:r>
           </a:p>
           <a:p>
@@ -5079,7 +5195,7 @@
                 </a:solidFill>
                 <a:latin typeface="Roboto"/>
               </a:rPr>
-              <a:t>Тип системы: ECM/СЭД с искусственным интеллектом</a:t>
+              <a:t>Снижение затрат — экономия на бумаге, печати, доставке и хранении документов</a:t>
             </a:r>
           </a:p>
           <a:p>
@@ -5097,7 +5213,7 @@
                 </a:solidFill>
                 <a:latin typeface="Roboto"/>
               </a:rPr>
-              <a:t>Аудитория: средний и крупный бизнес, госсектор</a:t>
+              <a:t>Прозрачность и контроль — отслеживание статуса документов и истории всех действий</a:t>
             </a:r>
           </a:p>
           <a:p>
@@ -5115,7 +5231,7 @@
                 </a:solidFill>
                 <a:latin typeface="Roboto"/>
               </a:rPr>
-              <a:t>Реестр отечественного ПО: включена, подтверждённая импортонезависимость</a:t>
+              <a:t>Безопасность данных — разграничение прав доступа, защита от потери и несанкционированного использования</a:t>
             </a:r>
           </a:p>
           <a:p>
@@ -5133,7 +5249,7 @@
                 </a:solidFill>
                 <a:latin typeface="Roboto"/>
               </a:rPr>
-              <a:t>Распространение: более 3 500 компаний, до 50 000 пользователей</a:t>
+              <a:t>Удалённая работа — доступ к документам из любой точки через веб и мобильные приложения</a:t>
             </a:r>
           </a:p>
         </p:txBody>
@@ -5146,7 +5262,7 @@
 </p:sld>
 </file>
 
-<file path=ppt/slides/slide6.xml><?xml version="1.0" encoding="utf-8"?>
+<file path=ppt/slides/slide5.xml><?xml version="1.0" encoding="utf-8"?>
 <p:sld xmlns:a="http://schemas.openxmlformats.org/drawingml/2006/main" xmlns:r="http://schemas.openxmlformats.org/officeDocument/2006/relationships" xmlns:p="http://schemas.openxmlformats.org/presentationml/2006/main">
   <p:cSld>
     <p:spTree>
@@ -5237,7 +5353,7 @@
                 </a:solidFill>
                 <a:latin typeface="Roboto Slab"/>
               </a:rPr>
-              <a:t>Архитектура и платформы</a:t>
+              <a:t>Directum RX — общие сведения</a:t>
             </a:r>
           </a:p>
         </p:txBody>
@@ -5278,7 +5394,7 @@
                 </a:solidFill>
                 <a:latin typeface="Roboto"/>
               </a:rPr>
-              <a:t>Микросервисная архитектура — гибкая, масштабируемая, легко настраиваемая экосистема</a:t>
+              <a:t>Разработчик: ООО «ДИРЕКТУМ» (Россия)</a:t>
             </a:r>
           </a:p>
           <a:p>
@@ -5296,7 +5412,7 @@
                 </a:solidFill>
                 <a:latin typeface="Roboto"/>
               </a:rPr>
-              <a:t>Веб-клиент — полная работа с документами и задачами через браузер</a:t>
+              <a:t>Тип системы: ECM/СЭД с искусственным интеллектом</a:t>
             </a:r>
           </a:p>
           <a:p>
@@ -5314,7 +5430,7 @@
                 </a:solidFill>
                 <a:latin typeface="Roboto"/>
               </a:rPr>
-              <a:t>Мобильные приложения — Directum Solo и Jazz для iOS и Android</a:t>
+              <a:t>Аудитория: средний и крупный бизнес, госсектор</a:t>
             </a:r>
           </a:p>
           <a:p>
@@ -5332,7 +5448,7 @@
                 </a:solidFill>
                 <a:latin typeface="Roboto"/>
               </a:rPr>
-              <a:t>Кроссплатформенность — поддержка Windows, Linux и macOS</a:t>
+              <a:t>Реестр отечественного ПО: включена, подтверждённая импортонезависимость</a:t>
             </a:r>
           </a:p>
           <a:p>
@@ -5350,7 +5466,7 @@
                 </a:solidFill>
                 <a:latin typeface="Roboto"/>
               </a:rPr>
-              <a:t>Интеграция — связь с 1С, ERP-системами, сервисами ЭДО (Synerdocs, Диадок)</a:t>
+              <a:t>Распространение: более 3 500 компаний, до 50 000 пользователей</a:t>
             </a:r>
           </a:p>
         </p:txBody>
@@ -5363,12 +5479,18 @@
 </p:sld>
 </file>
 
-<file path=ppt/slides/slide7.xml><?xml version="1.0" encoding="utf-8"?>
+<file path=ppt/slides/slide6.xml><?xml version="1.0" encoding="utf-8"?>
 <p:sld xmlns:a="http://schemas.openxmlformats.org/drawingml/2006/main" xmlns:r="http://schemas.openxmlformats.org/officeDocument/2006/relationships" xmlns:p="http://schemas.openxmlformats.org/presentationml/2006/main">
   <p:cSld>
     <p:spTree>
       <p:nvGrpSpPr>
-        <p:cNvPr id="1" name=""/>
+        <p:cNvPr id="1" name="">
+          <a:extLst>
+            <a:ext uri="{FF2B5EF4-FFF2-40B4-BE49-F238E27FC236}">
+              <a16:creationId xmlns:a16="http://schemas.microsoft.com/office/drawing/2014/main" id="{28E6AC09-BF06-9FED-F78E-258AC9174F0F}"/>
+            </a:ext>
+          </a:extLst>
+        </p:cNvPr>
         <p:cNvGrpSpPr/>
         <p:nvPr/>
       </p:nvGrpSpPr>
@@ -5382,7 +5504,13 @@
       </p:grpSpPr>
       <p:sp>
         <p:nvSpPr>
-          <p:cNvPr id="2" name="Rectangle 1"/>
+          <p:cNvPr id="2" name="Rectangle 1">
+            <a:extLst>
+              <a:ext uri="{FF2B5EF4-FFF2-40B4-BE49-F238E27FC236}">
+                <a16:creationId xmlns:a16="http://schemas.microsoft.com/office/drawing/2014/main" id="{242192AA-C726-AD3A-1D8B-ED799CB3F694}"/>
+              </a:ext>
+            </a:extLst>
+          </p:cNvPr>
           <p:cNvSpPr/>
           <p:nvPr/>
         </p:nvSpPr>
@@ -5427,14 +5555,20 @@
       </p:sp>
       <p:sp>
         <p:nvSpPr>
-          <p:cNvPr id="3" name="TextBox 2"/>
+          <p:cNvPr id="3" name="TextBox 2">
+            <a:extLst>
+              <a:ext uri="{FF2B5EF4-FFF2-40B4-BE49-F238E27FC236}">
+                <a16:creationId xmlns:a16="http://schemas.microsoft.com/office/drawing/2014/main" id="{CCFF5F41-8246-4919-6A2B-9655E6DD7510}"/>
+              </a:ext>
+            </a:extLst>
+          </p:cNvPr>
           <p:cNvSpPr txBox="1"/>
           <p:nvPr/>
         </p:nvSpPr>
         <p:spPr>
           <a:xfrm>
             <a:off x="841248" y="365760"/>
-            <a:ext cx="10515600" cy="1325880"/>
+            <a:ext cx="10515600" cy="492443"/>
           </a:xfrm>
           <a:prstGeom prst="rect">
             <a:avLst/>
@@ -5448,149 +5582,77 @@
           <a:lstStyle/>
           <a:p>
             <a:r>
-              <a:rPr sz="3200" b="1">
+              <a:rPr sz="3200" b="1" dirty="0" err="1">
                 <a:solidFill>
                   <a:srgbClr val="3B1E5E"/>
                 </a:solidFill>
                 <a:latin typeface="Roboto Slab"/>
               </a:rPr>
-              <a:t>Основные функции Directum RX</a:t>
-            </a:r>
-          </a:p>
-        </p:txBody>
-      </p:sp>
-      <p:sp>
-        <p:nvSpPr>
-          <p:cNvPr id="4" name="TextBox 3"/>
-          <p:cNvSpPr txBox="1"/>
+              <a:t>Directum</a:t>
+            </a:r>
+            <a:r>
+              <a:rPr sz="3200" b="1" dirty="0">
+                <a:solidFill>
+                  <a:srgbClr val="3B1E5E"/>
+                </a:solidFill>
+                <a:latin typeface="Roboto Slab"/>
+              </a:rPr>
+              <a:t> RX — </a:t>
+            </a:r>
+            <a:r>
+              <a:rPr lang="ru-RU" sz="3200" b="1" dirty="0">
+                <a:solidFill>
+                  <a:srgbClr val="3B1E5E"/>
+                </a:solidFill>
+                <a:latin typeface="Roboto Slab"/>
+              </a:rPr>
+              <a:t>скриншот из Реестра ПО</a:t>
+            </a:r>
+            <a:endParaRPr sz="3200" b="1" dirty="0">
+              <a:solidFill>
+                <a:srgbClr val="3B1E5E"/>
+              </a:solidFill>
+              <a:latin typeface="Roboto Slab"/>
+            </a:endParaRPr>
+          </a:p>
+        </p:txBody>
+      </p:sp>
+      <p:pic>
+        <p:nvPicPr>
+          <p:cNvPr id="6" name="Рисунок 5">
+            <a:extLst>
+              <a:ext uri="{FF2B5EF4-FFF2-40B4-BE49-F238E27FC236}">
+                <a16:creationId xmlns:a16="http://schemas.microsoft.com/office/drawing/2014/main" id="{FBE4FD63-493D-8ECA-42C3-4AC188D0777E}"/>
+              </a:ext>
+            </a:extLst>
+          </p:cNvPr>
+          <p:cNvPicPr>
+            <a:picLocks noChangeAspect="1"/>
+          </p:cNvPicPr>
           <p:nvPr/>
-        </p:nvSpPr>
+        </p:nvPicPr>
+        <p:blipFill>
+          <a:blip r:embed="rId2"/>
+          <a:stretch>
+            <a:fillRect/>
+          </a:stretch>
+        </p:blipFill>
         <p:spPr>
           <a:xfrm>
-            <a:off x="841248" y="1828800"/>
-            <a:ext cx="10515600" cy="4352544"/>
+            <a:off x="1236133" y="1705454"/>
+            <a:ext cx="9719733" cy="4786786"/>
           </a:xfrm>
           <a:prstGeom prst="rect">
             <a:avLst/>
           </a:prstGeom>
-          <a:noFill/>
         </p:spPr>
-        <p:txBody>
-          <a:bodyPr wrap="square" lIns="0" tIns="0" rIns="0" bIns="0" anchor="t">
-            <a:spAutoFit/>
-          </a:bodyPr>
-          <a:lstStyle/>
-          <a:p>
-            <a:pPr marL="285750" indent="-285750">
-              <a:spcAft>
-                <a:spcPts val="400"/>
-              </a:spcAft>
-              <a:buFont typeface="Arial"/>
-              <a:buChar char="•"/>
-            </a:pPr>
-            <a:r>
-              <a:rPr sz="1700" b="0">
-                <a:solidFill>
-                  <a:srgbClr val="1F1530"/>
-                </a:solidFill>
-                <a:latin typeface="Roboto"/>
-              </a:rPr>
-              <a:t>Управление документами — полный цикл, от создания и согласования до архивирования</a:t>
-            </a:r>
-          </a:p>
-          <a:p>
-            <a:pPr marL="285750" indent="-285750">
-              <a:spcAft>
-                <a:spcPts val="400"/>
-              </a:spcAft>
-              <a:buFont typeface="Arial"/>
-              <a:buChar char="•"/>
-            </a:pPr>
-            <a:r>
-              <a:rPr sz="1700" b="0">
-                <a:solidFill>
-                  <a:srgbClr val="1F1530"/>
-                </a:solidFill>
-                <a:latin typeface="Roboto"/>
-              </a:rPr>
-              <a:t>Управление процессами — маршруты согласования, поручения, контроль исполнения</a:t>
-            </a:r>
-          </a:p>
-          <a:p>
-            <a:pPr marL="285750" indent="-285750">
-              <a:spcAft>
-                <a:spcPts val="400"/>
-              </a:spcAft>
-              <a:buFont typeface="Arial"/>
-              <a:buChar char="•"/>
-            </a:pPr>
-            <a:r>
-              <a:rPr sz="1700" b="0">
-                <a:solidFill>
-                  <a:srgbClr val="1F1530"/>
-                </a:solidFill>
-                <a:latin typeface="Roboto"/>
-              </a:rPr>
-              <a:t>Делопроизводство — регистрация, рассмотрение корреспонденции, контроль исполнения</a:t>
-            </a:r>
-          </a:p>
-          <a:p>
-            <a:pPr marL="285750" indent="-285750">
-              <a:spcAft>
-                <a:spcPts val="400"/>
-              </a:spcAft>
-              <a:buFont typeface="Arial"/>
-              <a:buChar char="•"/>
-            </a:pPr>
-            <a:r>
-              <a:rPr sz="1700" b="0">
-                <a:solidFill>
-                  <a:srgbClr val="1F1530"/>
-                </a:solidFill>
-                <a:latin typeface="Roboto"/>
-              </a:rPr>
-              <a:t>Договоры — шаблоны, согласование, подписание ЭП, реестр обязательств</a:t>
-            </a:r>
-          </a:p>
-          <a:p>
-            <a:pPr marL="285750" indent="-285750">
-              <a:spcAft>
-                <a:spcPts val="400"/>
-              </a:spcAft>
-              <a:buFont typeface="Arial"/>
-              <a:buChar char="•"/>
-            </a:pPr>
-            <a:r>
-              <a:rPr sz="1700" b="0">
-                <a:solidFill>
-                  <a:srgbClr val="1F1530"/>
-                </a:solidFill>
-                <a:latin typeface="Roboto"/>
-              </a:rPr>
-              <a:t>Обмен с контрагентами — юридически значимый ЭДО через Synerdocs и Диадок</a:t>
-            </a:r>
-          </a:p>
-          <a:p>
-            <a:pPr marL="285750" indent="-285750">
-              <a:spcAft>
-                <a:spcPts val="400"/>
-              </a:spcAft>
-              <a:buFont typeface="Arial"/>
-              <a:buChar char="•"/>
-            </a:pPr>
-            <a:r>
-              <a:rPr sz="1700" b="0">
-                <a:solidFill>
-                  <a:srgbClr val="1F1530"/>
-                </a:solidFill>
-                <a:latin typeface="Roboto"/>
-              </a:rPr>
-              <a:t>Кадровые процессы (КЭДО) — приём, отпуска, командировки, удалённое подписание</a:t>
-            </a:r>
-          </a:p>
-        </p:txBody>
-      </p:sp>
+      </p:pic>
     </p:spTree>
+    <p:extLst>
+      <p:ext uri="{BB962C8B-B14F-4D97-AF65-F5344CB8AC3E}">
+        <p14:creationId xmlns:p14="http://schemas.microsoft.com/office/powerpoint/2010/main" val="3934065392"/>
+      </p:ext>
+    </p:extLst>
   </p:cSld>
   <p:clrMapOvr>
     <a:masterClrMapping/>
@@ -5598,7 +5660,7 @@
 </p:sld>
 </file>
 
-<file path=ppt/slides/slide8.xml><?xml version="1.0" encoding="utf-8"?>
+<file path=ppt/slides/slide7.xml><?xml version="1.0" encoding="utf-8"?>
 <p:sld xmlns:a="http://schemas.openxmlformats.org/drawingml/2006/main" xmlns:r="http://schemas.openxmlformats.org/officeDocument/2006/relationships" xmlns:p="http://schemas.openxmlformats.org/presentationml/2006/main">
   <p:cSld>
     <p:spTree>
@@ -5689,7 +5751,7 @@
                 </a:solidFill>
                 <a:latin typeface="Roboto Slab"/>
               </a:rPr>
-              <a:t>Интеллектуальные сервисы Directum Ario</a:t>
+              <a:t>Архитектура и платформы</a:t>
             </a:r>
           </a:p>
         </p:txBody>
@@ -5730,7 +5792,7 @@
                 </a:solidFill>
                 <a:latin typeface="Roboto"/>
               </a:rPr>
-              <a:t>Компьютерное зрение — распознавание сканов и фотографий документов (OCR)</a:t>
+              <a:t>Микросервисная архитектура — гибкая, масштабируемая, легко настраиваемая экосистема</a:t>
             </a:r>
           </a:p>
           <a:p>
@@ -5748,7 +5810,7 @@
                 </a:solidFill>
                 <a:latin typeface="Roboto"/>
               </a:rPr>
-              <a:t>Машинное обучение — автоматическая классификация документов по типам</a:t>
+              <a:t>Веб-клиент — полная работа с документами и задачами через браузер</a:t>
             </a:r>
           </a:p>
           <a:p>
@@ -5766,7 +5828,7 @@
                 </a:solidFill>
                 <a:latin typeface="Roboto"/>
               </a:rPr>
-              <a:t>Извлечение реквизитов — автозаполнение карточек документов из текста</a:t>
+              <a:t>Мобильные приложения — Directum Solo и Jazz для iOS и Android</a:t>
             </a:r>
           </a:p>
           <a:p>
@@ -5784,7 +5846,7 @@
                 </a:solidFill>
                 <a:latin typeface="Roboto"/>
               </a:rPr>
-              <a:t>Сравнение версий — поиск различий между редакциями договоров</a:t>
+              <a:t>Кроссплатформенность — поддержка Windows, Linux и macOS</a:t>
             </a:r>
           </a:p>
           <a:p>
@@ -5802,7 +5864,7 @@
                 </a:solidFill>
                 <a:latin typeface="Roboto"/>
               </a:rPr>
-              <a:t>Поиск рисков — выявление проблемных условий в текстах договоров</a:t>
+              <a:t>Интеграция — связь с 1С, ERP-системами, сервисами ЭДО (Synerdocs, Диадок)</a:t>
             </a:r>
           </a:p>
         </p:txBody>
@@ -5815,7 +5877,7 @@
 </p:sld>
 </file>
 
-<file path=ppt/slides/slide9.xml><?xml version="1.0" encoding="utf-8"?>
+<file path=ppt/slides/slide8.xml><?xml version="1.0" encoding="utf-8"?>
 <p:sld xmlns:a="http://schemas.openxmlformats.org/drawingml/2006/main" xmlns:r="http://schemas.openxmlformats.org/officeDocument/2006/relationships" xmlns:p="http://schemas.openxmlformats.org/presentationml/2006/main">
   <p:cSld>
     <p:spTree>
@@ -5906,7 +5968,7 @@
                 </a:solidFill>
                 <a:latin typeface="Roboto Slab"/>
               </a:rPr>
-              <a:t>Варианты поставки и тарифы</a:t>
+              <a:t>Основные функции Directum RX</a:t>
             </a:r>
           </a:p>
         </p:txBody>
@@ -5920,7 +5982,7 @@
         <p:spPr>
           <a:xfrm>
             <a:off x="841248" y="1828800"/>
-            <a:ext cx="5074920" cy="4352544"/>
+            <a:ext cx="10515600" cy="4352544"/>
           </a:xfrm>
           <a:prstGeom prst="rect">
             <a:avLst/>
@@ -5933,25 +5995,6 @@
           </a:bodyPr>
           <a:lstStyle/>
           <a:p>
-            <a:pPr>
-              <a:spcBef>
-                <a:spcPts val="0"/>
-              </a:spcBef>
-              <a:spcAft>
-                <a:spcPts val="600"/>
-              </a:spcAft>
-            </a:pPr>
-            <a:r>
-              <a:rPr sz="2000" b="1">
-                <a:solidFill>
-                  <a:srgbClr val="3B1E5E"/>
-                </a:solidFill>
-                <a:latin typeface="Roboto"/>
-              </a:rPr>
-              <a:t>Локальная (On-Premise)</a:t>
-            </a:r>
-          </a:p>
-          <a:p>
             <a:pPr marL="285750" indent="-285750">
               <a:spcAft>
                 <a:spcPts val="400"/>
@@ -5966,7 +6009,7 @@
                 </a:solidFill>
                 <a:latin typeface="Roboto"/>
               </a:rPr>
-              <a:t>Установка на серверах заказчика</a:t>
+              <a:t>Управление документами — полный цикл, от создания и согласования до архивирования</a:t>
             </a:r>
           </a:p>
           <a:p>
@@ -5984,7 +6027,7 @@
                 </a:solidFill>
                 <a:latin typeface="Roboto"/>
               </a:rPr>
-              <a:t>Полный контроль данных</a:t>
+              <a:t>Управление процессами — маршруты согласования, поручения, контроль исполнения</a:t>
             </a:r>
           </a:p>
           <a:p>
@@ -6002,7 +6045,7 @@
                 </a:solidFill>
                 <a:latin typeface="Roboto"/>
               </a:rPr>
-              <a:t>Тарифы: Basic, Enterprise, Intelligence</a:t>
+              <a:t>Делопроизводство — регистрация, рассмотрение корреспонденции, контроль исполнения</a:t>
             </a:r>
           </a:p>
           <a:p>
@@ -6020,21 +6063,127 @@
                 </a:solidFill>
                 <a:latin typeface="Roboto"/>
               </a:rPr>
-              <a:t>Подходит для крупных компаний</a:t>
-            </a:r>
-          </a:p>
-        </p:txBody>
-      </p:sp>
-      <p:sp>
-        <p:nvSpPr>
-          <p:cNvPr id="5" name="TextBox 4"/>
+              <a:t>Договоры — шаблоны, согласование, подписание ЭП, реестр обязательств</a:t>
+            </a:r>
+          </a:p>
+          <a:p>
+            <a:pPr marL="285750" indent="-285750">
+              <a:spcAft>
+                <a:spcPts val="400"/>
+              </a:spcAft>
+              <a:buFont typeface="Arial"/>
+              <a:buChar char="•"/>
+            </a:pPr>
+            <a:r>
+              <a:rPr sz="1700" b="0">
+                <a:solidFill>
+                  <a:srgbClr val="1F1530"/>
+                </a:solidFill>
+                <a:latin typeface="Roboto"/>
+              </a:rPr>
+              <a:t>Обмен с контрагентами — юридически значимый ЭДО через Synerdocs и Диадок</a:t>
+            </a:r>
+          </a:p>
+          <a:p>
+            <a:pPr marL="285750" indent="-285750">
+              <a:spcAft>
+                <a:spcPts val="400"/>
+              </a:spcAft>
+              <a:buFont typeface="Arial"/>
+              <a:buChar char="•"/>
+            </a:pPr>
+            <a:r>
+              <a:rPr sz="1700" b="0">
+                <a:solidFill>
+                  <a:srgbClr val="1F1530"/>
+                </a:solidFill>
+                <a:latin typeface="Roboto"/>
+              </a:rPr>
+              <a:t>Кадровые процессы (КЭДО) — приём, отпуска, командировки, удалённое подписание</a:t>
+            </a:r>
+          </a:p>
+        </p:txBody>
+      </p:sp>
+    </p:spTree>
+  </p:cSld>
+  <p:clrMapOvr>
+    <a:masterClrMapping/>
+  </p:clrMapOvr>
+</p:sld>
+</file>
+
+<file path=ppt/slides/slide9.xml><?xml version="1.0" encoding="utf-8"?>
+<p:sld xmlns:a="http://schemas.openxmlformats.org/drawingml/2006/main" xmlns:r="http://schemas.openxmlformats.org/officeDocument/2006/relationships" xmlns:p="http://schemas.openxmlformats.org/presentationml/2006/main">
+  <p:cSld>
+    <p:spTree>
+      <p:nvGrpSpPr>
+        <p:cNvPr id="1" name=""/>
+        <p:cNvGrpSpPr/>
+        <p:nvPr/>
+      </p:nvGrpSpPr>
+      <p:grpSpPr>
+        <a:xfrm>
+          <a:off x="0" y="0"/>
+          <a:ext cx="0" cy="0"/>
+          <a:chOff x="0" y="0"/>
+          <a:chExt cx="0" cy="0"/>
+        </a:xfrm>
+      </p:grpSpPr>
+      <p:sp>
+        <p:nvSpPr>
+          <p:cNvPr id="2" name="Rectangle 1"/>
+          <p:cNvSpPr/>
+          <p:nvPr/>
+        </p:nvSpPr>
+        <p:spPr>
+          <a:xfrm>
+            <a:off x="457200" y="1316736"/>
+            <a:ext cx="685800" cy="38404"/>
+          </a:xfrm>
+          <a:prstGeom prst="rect">
+            <a:avLst/>
+          </a:prstGeom>
+          <a:solidFill>
+            <a:srgbClr val="3B1E5E"/>
+          </a:solidFill>
+          <a:ln>
+            <a:noFill/>
+          </a:ln>
+          <a:effectLst/>
+        </p:spPr>
+        <p:style>
+          <a:lnRef idx="1">
+            <a:schemeClr val="accent1"/>
+          </a:lnRef>
+          <a:fillRef idx="3">
+            <a:schemeClr val="accent1"/>
+          </a:fillRef>
+          <a:effectRef idx="2">
+            <a:schemeClr val="accent1"/>
+          </a:effectRef>
+          <a:fontRef idx="minor">
+            <a:schemeClr val="lt1"/>
+          </a:fontRef>
+        </p:style>
+        <p:txBody>
+          <a:bodyPr rtlCol="0" anchor="ctr"/>
+          <a:lstStyle/>
+          <a:p>
+            <a:pPr algn="ctr"/>
+            <a:endParaRPr/>
+          </a:p>
+        </p:txBody>
+      </p:sp>
+      <p:sp>
+        <p:nvSpPr>
+          <p:cNvPr id="3" name="TextBox 2"/>
           <p:cNvSpPr txBox="1"/>
           <p:nvPr/>
         </p:nvSpPr>
         <p:spPr>
           <a:xfrm>
-            <a:off x="6272784" y="1828800"/>
-            <a:ext cx="5074920" cy="4352544"/>
+            <a:off x="841248" y="365760"/>
+            <a:ext cx="10515600" cy="1325880"/>
           </a:xfrm>
           <a:prstGeom prst="rect">
             <a:avLst/>
@@ -6047,24 +6196,39 @@
           </a:bodyPr>
           <a:lstStyle/>
           <a:p>
-            <a:pPr>
-              <a:spcBef>
-                <a:spcPts val="0"/>
-              </a:spcBef>
-              <a:spcAft>
-                <a:spcPts val="600"/>
-              </a:spcAft>
-            </a:pPr>
-            <a:r>
-              <a:rPr sz="2000" b="1">
+            <a:r>
+              <a:rPr sz="3200" b="1">
                 <a:solidFill>
                   <a:srgbClr val="3B1E5E"/>
                 </a:solidFill>
-                <a:latin typeface="Roboto"/>
-              </a:rPr>
-              <a:t>Облачная (SaaS)</a:t>
-            </a:r>
-          </a:p>
+                <a:latin typeface="Roboto Slab"/>
+              </a:rPr>
+              <a:t>Интеллектуальные сервисы Directum Ario</a:t>
+            </a:r>
+          </a:p>
+        </p:txBody>
+      </p:sp>
+      <p:sp>
+        <p:nvSpPr>
+          <p:cNvPr id="4" name="TextBox 3"/>
+          <p:cNvSpPr txBox="1"/>
+          <p:nvPr/>
+        </p:nvSpPr>
+        <p:spPr>
+          <a:xfrm>
+            <a:off x="841248" y="1828800"/>
+            <a:ext cx="10515600" cy="4352544"/>
+          </a:xfrm>
+          <a:prstGeom prst="rect">
+            <a:avLst/>
+          </a:prstGeom>
+          <a:noFill/>
+        </p:spPr>
+        <p:txBody>
+          <a:bodyPr wrap="square" lIns="0" tIns="0" rIns="0" bIns="0" anchor="t">
+            <a:spAutoFit/>
+          </a:bodyPr>
+          <a:lstStyle/>
           <a:p>
             <a:pPr marL="285750" indent="-285750">
               <a:spcAft>
@@ -6080,7 +6244,7 @@
                 </a:solidFill>
                 <a:latin typeface="Roboto"/>
               </a:rPr>
-              <a:t>Размещение в ЦОД на территории РФ</a:t>
+              <a:t>Компьютерное зрение — распознавание сканов и фотографий документов (OCR)</a:t>
             </a:r>
           </a:p>
           <a:p>
@@ -6098,7 +6262,7 @@
                 </a:solidFill>
                 <a:latin typeface="Roboto"/>
               </a:rPr>
-              <a:t>Быстрый старт, без капвложений</a:t>
+              <a:t>Машинное обучение — автоматическая классификация документов по типам</a:t>
             </a:r>
           </a:p>
           <a:p>
@@ -6116,7 +6280,7 @@
                 </a:solidFill>
                 <a:latin typeface="Roboto"/>
               </a:rPr>
-              <a:t>Тарифы: RX100 (до 200), DRX200</a:t>
+              <a:t>Извлечение реквизитов — автозаполнение карточек документов из текста</a:t>
             </a:r>
           </a:p>
           <a:p>
@@ -6134,7 +6298,25 @@
                 </a:solidFill>
                 <a:latin typeface="Roboto"/>
               </a:rPr>
-              <a:t>Подходит для среднего и малого бизнеса</a:t>
+              <a:t>Сравнение версий — поиск различий между редакциями договоров</a:t>
+            </a:r>
+          </a:p>
+          <a:p>
+            <a:pPr marL="285750" indent="-285750">
+              <a:spcAft>
+                <a:spcPts val="400"/>
+              </a:spcAft>
+              <a:buFont typeface="Arial"/>
+              <a:buChar char="•"/>
+            </a:pPr>
+            <a:r>
+              <a:rPr sz="1700" b="0">
+                <a:solidFill>
+                  <a:srgbClr val="1F1530"/>
+                </a:solidFill>
+                <a:latin typeface="Roboto"/>
+              </a:rPr>
+              <a:t>Поиск рисков — выявление проблемных условий в текстах договоров</a:t>
             </a:r>
           </a:p>
         </p:txBody>

</xml_diff>